<commit_message>
Cartridge Usage in the user guide, the i-STAT manager deck (page 6 slide) and the landing page
Co-Authored-By: Claude Fable 5.1 <noreply@anthropic.com>
</commit_message>
<xml_diff>
--- a/PQ_Report_Generator_Overview_for_Managers_iSTAT.pptx
+++ b/PQ_Report_Generator_Overview_for_Managers_iSTAT.pptx
@@ -15,6 +15,7 @@
     <p:sldId id="263" r:id="rId14"/>
     <p:sldId id="264" r:id="rId15"/>
     <p:sldId id="265" r:id="rId16"/>
+    <p:sldId id="266" r:id="rId17"/>
   </p:sldIdLst>
   <p:notesMasterIdLst>
     <p:notesMasterId r:id="rId19"/>
@@ -1549,6 +1550,761 @@
                   <a:srgbClr val="01485C"/>
                 </a:solidFill>
               </a:rPr>
+              <a:t>How it protects the data</a:t>
+            </a:r>
+          </a:p>
+        </p:txBody>
+      </p:sp>
+      <p:sp>
+        <p:nvSpPr>
+          <p:cNvPr id="19" name="Rounded Rectangle 18"/>
+          <p:cNvSpPr/>
+          <p:nvPr/>
+        </p:nvSpPr>
+        <p:spPr>
+          <a:xfrm>
+            <a:off x="548640" y="1280160"/>
+            <a:ext cx="5440680" cy="2103120"/>
+          </a:xfrm>
+          <a:prstGeom prst="roundRect">
+            <a:avLst>
+              <a:gd name="adj" fmla="val 8000"/>
+            </a:avLst>
+          </a:prstGeom>
+          <a:solidFill>
+            <a:srgbClr val="E5F2F0"/>
+          </a:solidFill>
+          <a:ln>
+            <a:noFill/>
+          </a:ln>
+        </p:spPr>
+        <p:style>
+          <a:lnRef idx="1">
+            <a:schemeClr val="accent1"/>
+          </a:lnRef>
+          <a:fillRef idx="3">
+            <a:schemeClr val="accent1"/>
+          </a:fillRef>
+          <a:effectRef idx="2">
+            <a:schemeClr val="accent1"/>
+          </a:effectRef>
+          <a:fontRef idx="minor">
+            <a:schemeClr val="lt1"/>
+          </a:fontRef>
+        </p:style>
+        <p:txBody>
+          <a:bodyPr rtlCol="0" anchor="ctr"/>
+          <a:lstStyle/>
+          <a:p>
+            <a:pPr algn="ctr"/>
+          </a:p>
+        </p:txBody>
+      </p:sp>
+      <p:sp>
+        <p:nvSpPr>
+          <p:cNvPr id="20" name="TextBox 19"/>
+          <p:cNvSpPr txBox="1"/>
+          <p:nvPr/>
+        </p:nvSpPr>
+        <p:spPr>
+          <a:xfrm>
+            <a:off x="777240" y="1417319"/>
+            <a:ext cx="4983480" cy="457200"/>
+          </a:xfrm>
+          <a:prstGeom prst="rect">
+            <a:avLst/>
+          </a:prstGeom>
+          <a:noFill/>
+        </p:spPr>
+        <p:txBody>
+          <a:bodyPr wrap="square">
+            <a:spAutoFit/>
+          </a:bodyPr>
+          <a:lstStyle/>
+          <a:p>
+            <a:pPr algn="l">
+              <a:spcAft>
+                <a:spcPts val="600"/>
+              </a:spcAft>
+            </a:pPr>
+            <a:r>
+              <a:rPr sz="1500" b="1">
+                <a:solidFill>
+                  <a:srgbClr val="01485C"/>
+                </a:solidFill>
+              </a:rPr>
+              <a:t>Runs from an encrypted USB drive</a:t>
+            </a:r>
+          </a:p>
+        </p:txBody>
+      </p:sp>
+      <p:sp>
+        <p:nvSpPr>
+          <p:cNvPr id="21" name="TextBox 20"/>
+          <p:cNvSpPr txBox="1"/>
+          <p:nvPr/>
+        </p:nvSpPr>
+        <p:spPr>
+          <a:xfrm>
+            <a:off x="777240" y="1847088"/>
+            <a:ext cx="4983480" cy="1463039"/>
+          </a:xfrm>
+          <a:prstGeom prst="rect">
+            <a:avLst/>
+          </a:prstGeom>
+          <a:noFill/>
+        </p:spPr>
+        <p:txBody>
+          <a:bodyPr wrap="square">
+            <a:spAutoFit/>
+          </a:bodyPr>
+          <a:lstStyle/>
+          <a:p>
+            <a:pPr algn="l">
+              <a:spcAft>
+                <a:spcPts val="600"/>
+              </a:spcAft>
+            </a:pPr>
+            <a:r>
+              <a:rPr sz="1200" b="0">
+                <a:solidFill>
+                  <a:srgbClr val="17272E"/>
+                </a:solidFill>
+              </a:rPr>
+              <a:t>Its own Python runtime, no installation, no admin rights, no changes to the PC. BitLocker To Go encrypts the whole drive.</a:t>
+            </a:r>
+          </a:p>
+        </p:txBody>
+      </p:sp>
+      <p:sp>
+        <p:nvSpPr>
+          <p:cNvPr id="22" name="Rounded Rectangle 21"/>
+          <p:cNvSpPr/>
+          <p:nvPr/>
+        </p:nvSpPr>
+        <p:spPr>
+          <a:xfrm>
+            <a:off x="6172200" y="1280160"/>
+            <a:ext cx="5440680" cy="2103120"/>
+          </a:xfrm>
+          <a:prstGeom prst="roundRect">
+            <a:avLst>
+              <a:gd name="adj" fmla="val 8000"/>
+            </a:avLst>
+          </a:prstGeom>
+          <a:solidFill>
+            <a:srgbClr val="E5F2F0"/>
+          </a:solidFill>
+          <a:ln>
+            <a:noFill/>
+          </a:ln>
+        </p:spPr>
+        <p:style>
+          <a:lnRef idx="1">
+            <a:schemeClr val="accent1"/>
+          </a:lnRef>
+          <a:fillRef idx="3">
+            <a:schemeClr val="accent1"/>
+          </a:fillRef>
+          <a:effectRef idx="2">
+            <a:schemeClr val="accent1"/>
+          </a:effectRef>
+          <a:fontRef idx="minor">
+            <a:schemeClr val="lt1"/>
+          </a:fontRef>
+        </p:style>
+        <p:txBody>
+          <a:bodyPr rtlCol="0" anchor="ctr"/>
+          <a:lstStyle/>
+          <a:p>
+            <a:pPr algn="ctr"/>
+          </a:p>
+        </p:txBody>
+      </p:sp>
+      <p:sp>
+        <p:nvSpPr>
+          <p:cNvPr id="23" name="TextBox 22"/>
+          <p:cNvSpPr txBox="1"/>
+          <p:nvPr/>
+        </p:nvSpPr>
+        <p:spPr>
+          <a:xfrm>
+            <a:off x="6400800" y="1417319"/>
+            <a:ext cx="4983480" cy="457200"/>
+          </a:xfrm>
+          <a:prstGeom prst="rect">
+            <a:avLst/>
+          </a:prstGeom>
+          <a:noFill/>
+        </p:spPr>
+        <p:txBody>
+          <a:bodyPr wrap="square">
+            <a:spAutoFit/>
+          </a:bodyPr>
+          <a:lstStyle/>
+          <a:p>
+            <a:pPr algn="l">
+              <a:spcAft>
+                <a:spcPts val="600"/>
+              </a:spcAft>
+            </a:pPr>
+            <a:r>
+              <a:rPr sz="1500" b="1">
+                <a:solidFill>
+                  <a:srgbClr val="01485C"/>
+                </a:solidFill>
+              </a:rPr>
+              <a:t>Offline by enforcement</a:t>
+            </a:r>
+          </a:p>
+        </p:txBody>
+      </p:sp>
+      <p:sp>
+        <p:nvSpPr>
+          <p:cNvPr id="24" name="TextBox 23"/>
+          <p:cNvSpPr txBox="1"/>
+          <p:nvPr/>
+        </p:nvSpPr>
+        <p:spPr>
+          <a:xfrm>
+            <a:off x="6400800" y="1847088"/>
+            <a:ext cx="4983480" cy="1463039"/>
+          </a:xfrm>
+          <a:prstGeom prst="rect">
+            <a:avLst/>
+          </a:prstGeom>
+          <a:noFill/>
+        </p:spPr>
+        <p:txBody>
+          <a:bodyPr wrap="square">
+            <a:spAutoFit/>
+          </a:bodyPr>
+          <a:lstStyle/>
+          <a:p>
+            <a:pPr algn="l">
+              <a:spcAft>
+                <a:spcPts val="600"/>
+              </a:spcAft>
+            </a:pPr>
+            <a:r>
+              <a:rPr sz="1200" b="0">
+                <a:solidFill>
+                  <a:srgbClr val="17272E"/>
+                </a:solidFill>
+              </a:rPr>
+              <a:t>All three servers bind to the local machine only, and a runtime guard blocks and logs any attempt to reach the network. Zero outbound connections, ever.</a:t>
+            </a:r>
+          </a:p>
+        </p:txBody>
+      </p:sp>
+      <p:sp>
+        <p:nvSpPr>
+          <p:cNvPr id="25" name="Rounded Rectangle 24"/>
+          <p:cNvSpPr/>
+          <p:nvPr/>
+        </p:nvSpPr>
+        <p:spPr>
+          <a:xfrm>
+            <a:off x="548640" y="3566160"/>
+            <a:ext cx="5440680" cy="2103120"/>
+          </a:xfrm>
+          <a:prstGeom prst="roundRect">
+            <a:avLst>
+              <a:gd name="adj" fmla="val 8000"/>
+            </a:avLst>
+          </a:prstGeom>
+          <a:solidFill>
+            <a:srgbClr val="FDF0E4"/>
+          </a:solidFill>
+          <a:ln>
+            <a:noFill/>
+          </a:ln>
+        </p:spPr>
+        <p:style>
+          <a:lnRef idx="1">
+            <a:schemeClr val="accent1"/>
+          </a:lnRef>
+          <a:fillRef idx="3">
+            <a:schemeClr val="accent1"/>
+          </a:fillRef>
+          <a:effectRef idx="2">
+            <a:schemeClr val="accent1"/>
+          </a:effectRef>
+          <a:fontRef idx="minor">
+            <a:schemeClr val="lt1"/>
+          </a:fontRef>
+        </p:style>
+        <p:txBody>
+          <a:bodyPr rtlCol="0" anchor="ctr"/>
+          <a:lstStyle/>
+          <a:p>
+            <a:pPr algn="ctr"/>
+          </a:p>
+        </p:txBody>
+      </p:sp>
+      <p:sp>
+        <p:nvSpPr>
+          <p:cNvPr id="26" name="TextBox 25"/>
+          <p:cNvSpPr txBox="1"/>
+          <p:nvPr/>
+        </p:nvSpPr>
+        <p:spPr>
+          <a:xfrm>
+            <a:off x="777240" y="3703320"/>
+            <a:ext cx="4983480" cy="457200"/>
+          </a:xfrm>
+          <a:prstGeom prst="rect">
+            <a:avLst/>
+          </a:prstGeom>
+          <a:noFill/>
+        </p:spPr>
+        <p:txBody>
+          <a:bodyPr wrap="square">
+            <a:spAutoFit/>
+          </a:bodyPr>
+          <a:lstStyle/>
+          <a:p>
+            <a:pPr algn="l">
+              <a:spcAft>
+                <a:spcPts val="600"/>
+              </a:spcAft>
+            </a:pPr>
+            <a:r>
+              <a:rPr sz="1500" b="1">
+                <a:solidFill>
+                  <a:srgbClr val="B4540A"/>
+                </a:solidFill>
+              </a:rPr>
+              <a:t>Named staff data encrypted</a:t>
+            </a:r>
+          </a:p>
+        </p:txBody>
+      </p:sp>
+      <p:sp>
+        <p:nvSpPr>
+          <p:cNvPr id="27" name="TextBox 26"/>
+          <p:cNvSpPr txBox="1"/>
+          <p:nvPr/>
+        </p:nvSpPr>
+        <p:spPr>
+          <a:xfrm>
+            <a:off x="777240" y="4133087"/>
+            <a:ext cx="4983480" cy="1463039"/>
+          </a:xfrm>
+          <a:prstGeom prst="rect">
+            <a:avLst/>
+          </a:prstGeom>
+          <a:noFill/>
+        </p:spPr>
+        <p:txBody>
+          <a:bodyPr wrap="square">
+            <a:spAutoFit/>
+          </a:bodyPr>
+          <a:lstStyle/>
+          <a:p>
+            <a:pPr algn="l">
+              <a:spcAft>
+                <a:spcPts val="600"/>
+              </a:spcAft>
+            </a:pPr>
+            <a:r>
+              <a:rPr sz="1200" b="0">
+                <a:solidFill>
+                  <a:srgbClr val="17272E"/>
+                </a:solidFill>
+              </a:rPr>
+              <a:t>The rolling staff and device history is AES-encrypted with a password that is never stored. Reports cannot be generated until it is unlocked.</a:t>
+            </a:r>
+          </a:p>
+        </p:txBody>
+      </p:sp>
+      <p:sp>
+        <p:nvSpPr>
+          <p:cNvPr id="28" name="Rounded Rectangle 27"/>
+          <p:cNvSpPr/>
+          <p:nvPr/>
+        </p:nvSpPr>
+        <p:spPr>
+          <a:xfrm>
+            <a:off x="6172200" y="3566160"/>
+            <a:ext cx="5440680" cy="2103120"/>
+          </a:xfrm>
+          <a:prstGeom prst="roundRect">
+            <a:avLst>
+              <a:gd name="adj" fmla="val 8000"/>
+            </a:avLst>
+          </a:prstGeom>
+          <a:solidFill>
+            <a:srgbClr val="E5F2F0"/>
+          </a:solidFill>
+          <a:ln>
+            <a:noFill/>
+          </a:ln>
+        </p:spPr>
+        <p:style>
+          <a:lnRef idx="1">
+            <a:schemeClr val="accent1"/>
+          </a:lnRef>
+          <a:fillRef idx="3">
+            <a:schemeClr val="accent1"/>
+          </a:fillRef>
+          <a:effectRef idx="2">
+            <a:schemeClr val="accent1"/>
+          </a:effectRef>
+          <a:fontRef idx="minor">
+            <a:schemeClr val="lt1"/>
+          </a:fontRef>
+        </p:style>
+        <p:txBody>
+          <a:bodyPr rtlCol="0" anchor="ctr"/>
+          <a:lstStyle/>
+          <a:p>
+            <a:pPr algn="ctr"/>
+          </a:p>
+        </p:txBody>
+      </p:sp>
+      <p:sp>
+        <p:nvSpPr>
+          <p:cNvPr id="29" name="TextBox 28"/>
+          <p:cNvSpPr txBox="1"/>
+          <p:nvPr/>
+        </p:nvSpPr>
+        <p:spPr>
+          <a:xfrm>
+            <a:off x="6400800" y="3703320"/>
+            <a:ext cx="4983480" cy="457200"/>
+          </a:xfrm>
+          <a:prstGeom prst="rect">
+            <a:avLst/>
+          </a:prstGeom>
+          <a:noFill/>
+        </p:spPr>
+        <p:txBody>
+          <a:bodyPr wrap="square">
+            <a:spAutoFit/>
+          </a:bodyPr>
+          <a:lstStyle/>
+          <a:p>
+            <a:pPr algn="l">
+              <a:spcAft>
+                <a:spcPts val="600"/>
+              </a:spcAft>
+            </a:pPr>
+            <a:r>
+              <a:rPr sz="1500" b="1">
+                <a:solidFill>
+                  <a:srgbClr val="01485C"/>
+                </a:solidFill>
+              </a:rPr>
+              <a:t>Controlled roll-out</a:t>
+            </a:r>
+          </a:p>
+        </p:txBody>
+      </p:sp>
+      <p:sp>
+        <p:nvSpPr>
+          <p:cNvPr id="30" name="TextBox 29"/>
+          <p:cNvSpPr txBox="1"/>
+          <p:nvPr/>
+        </p:nvSpPr>
+        <p:spPr>
+          <a:xfrm>
+            <a:off x="6400800" y="4133087"/>
+            <a:ext cx="4983480" cy="1463039"/>
+          </a:xfrm>
+          <a:prstGeom prst="rect">
+            <a:avLst/>
+          </a:prstGeom>
+          <a:noFill/>
+        </p:spPr>
+        <p:txBody>
+          <a:bodyPr wrap="square">
+            <a:spAutoFit/>
+          </a:bodyPr>
+          <a:lstStyle/>
+          <a:p>
+            <a:pPr algn="l">
+              <a:spcAft>
+                <a:spcPts val="600"/>
+              </a:spcAft>
+            </a:pPr>
+            <a:r>
+              <a:rPr sz="1200" b="0">
+                <a:solidFill>
+                  <a:srgbClr val="17272E"/>
+                </a:solidFill>
+              </a:rPr>
+              <a:t>It runs only on PCs approved by the PoC lead, reviewed on the 12-month QIS cycle, with an audit trail of every launch and every report generated.</a:t>
+            </a:r>
+          </a:p>
+        </p:txBody>
+      </p:sp>
+      <p:sp>
+        <p:nvSpPr>
+          <p:cNvPr id="31" name="TextBox 30"/>
+          <p:cNvSpPr txBox="1"/>
+          <p:nvPr/>
+        </p:nvSpPr>
+        <p:spPr>
+          <a:xfrm>
+            <a:off x="548640" y="5806440"/>
+            <a:ext cx="11064240" cy="411480"/>
+          </a:xfrm>
+          <a:prstGeom prst="rect">
+            <a:avLst/>
+          </a:prstGeom>
+          <a:noFill/>
+        </p:spPr>
+        <p:txBody>
+          <a:bodyPr wrap="square">
+            <a:spAutoFit/>
+          </a:bodyPr>
+          <a:lstStyle/>
+          <a:p>
+            <a:pPr algn="l">
+              <a:spcAft>
+                <a:spcPts val="600"/>
+              </a:spcAft>
+            </a:pPr>
+            <a:r>
+              <a:rPr sz="1100" b="0">
+                <a:solidFill>
+                  <a:srgbClr val="5F7178"/>
+                </a:solidFill>
+              </a:rPr>
+              <a:t>Full detail for IT: SECURITY_README.md on the drive and the Security Briefing deck.</a:t>
+            </a:r>
+          </a:p>
+        </p:txBody>
+      </p:sp>
+      <p:sp>
+        <p:nvSpPr>
+          <p:cNvPr id="32" name="TextBox 31"/>
+          <p:cNvSpPr txBox="1"/>
+          <p:nvPr/>
+        </p:nvSpPr>
+        <p:spPr>
+          <a:xfrm>
+            <a:off x="548640" y="6263640"/>
+            <a:ext cx="11064240" cy="365760"/>
+          </a:xfrm>
+          <a:prstGeom prst="rect">
+            <a:avLst/>
+          </a:prstGeom>
+          <a:noFill/>
+        </p:spPr>
+        <p:txBody>
+          <a:bodyPr wrap="square">
+            <a:spAutoFit/>
+          </a:bodyPr>
+          <a:lstStyle/>
+          <a:p>
+            <a:pPr algn="l">
+              <a:spcAft>
+                <a:spcPts val="600"/>
+              </a:spcAft>
+            </a:pPr>
+            <a:r>
+              <a:rPr sz="1100" b="0">
+                <a:solidFill>
+                  <a:srgbClr val="5F7178"/>
+                </a:solidFill>
+              </a:rPr>
+              <a:t>Conceived, designed and built by Craig MacKenzie · Chemistry Department, Townsville Group Laboratory · Pathology Queensland</a:t>
+            </a:r>
+          </a:p>
+        </p:txBody>
+      </p:sp>
+    </p:spTree>
+  </p:cSld>
+  <p:clrMapOvr>
+    <a:masterClrMapping/>
+  </p:clrMapOvr>
+</p:sld>
+</file>
+
+<file path=ppt/slides/slide11.xml><?xml version="1.0" encoding="utf-8"?>
+<p:sld xmlns:a="http://schemas.openxmlformats.org/drawingml/2006/main" xmlns:p="http://schemas.openxmlformats.org/presentationml/2006/main" xmlns:r="http://schemas.openxmlformats.org/officeDocument/2006/relationships">
+  <p:cSld>
+    <p:spTree>
+      <p:nvGrpSpPr>
+        <p:cNvPr id="1" name=""/>
+        <p:cNvGrpSpPr/>
+        <p:nvPr/>
+      </p:nvGrpSpPr>
+      <p:grpSpPr/>
+      <p:sp>
+        <p:nvSpPr>
+          <p:cNvPr id="12" name="Shape 7"/>
+          <p:cNvSpPr/>
+          <p:nvPr/>
+        </p:nvSpPr>
+        <p:spPr>
+          <a:xfrm>
+            <a:off x="0" y="6793992"/>
+            <a:ext cx="2040636" cy="64008"/>
+          </a:xfrm>
+          <a:prstGeom prst="rect">
+            <a:avLst/>
+          </a:prstGeom>
+          <a:solidFill>
+            <a:srgbClr val="01485C"/>
+          </a:solidFill>
+          <a:ln/>
+        </p:spPr>
+        <p:txBody>
+          <a:bodyPr/>
+          <a:p/>
+        </p:txBody>
+      </p:sp>
+      <p:sp>
+        <p:nvSpPr>
+          <p:cNvPr id="13" name="Shape 8"/>
+          <p:cNvSpPr/>
+          <p:nvPr/>
+        </p:nvSpPr>
+        <p:spPr>
+          <a:xfrm>
+            <a:off x="2031492" y="6793992"/>
+            <a:ext cx="2040636" cy="64008"/>
+          </a:xfrm>
+          <a:prstGeom prst="rect">
+            <a:avLst/>
+          </a:prstGeom>
+          <a:solidFill>
+            <a:srgbClr val="146175"/>
+          </a:solidFill>
+          <a:ln/>
+        </p:spPr>
+        <p:txBody>
+          <a:bodyPr/>
+          <a:p/>
+        </p:txBody>
+      </p:sp>
+      <p:sp>
+        <p:nvSpPr>
+          <p:cNvPr id="14" name="Shape 9"/>
+          <p:cNvSpPr/>
+          <p:nvPr/>
+        </p:nvSpPr>
+        <p:spPr>
+          <a:xfrm>
+            <a:off x="4062984" y="6793992"/>
+            <a:ext cx="2040636" cy="64008"/>
+          </a:xfrm>
+          <a:prstGeom prst="rect">
+            <a:avLst/>
+          </a:prstGeom>
+          <a:solidFill>
+            <a:srgbClr val="11B5AE"/>
+          </a:solidFill>
+          <a:ln/>
+        </p:spPr>
+        <p:txBody>
+          <a:bodyPr/>
+          <a:p/>
+        </p:txBody>
+      </p:sp>
+      <p:sp>
+        <p:nvSpPr>
+          <p:cNvPr id="15" name="Shape 10"/>
+          <p:cNvSpPr/>
+          <p:nvPr/>
+        </p:nvSpPr>
+        <p:spPr>
+          <a:xfrm>
+            <a:off x="6094476" y="6793992"/>
+            <a:ext cx="2040636" cy="64008"/>
+          </a:xfrm>
+          <a:prstGeom prst="rect">
+            <a:avLst/>
+          </a:prstGeom>
+          <a:solidFill>
+            <a:srgbClr val="6CCAD4"/>
+          </a:solidFill>
+          <a:ln/>
+        </p:spPr>
+        <p:txBody>
+          <a:bodyPr/>
+          <a:p/>
+        </p:txBody>
+      </p:sp>
+      <p:sp>
+        <p:nvSpPr>
+          <p:cNvPr id="16" name="Shape 11"/>
+          <p:cNvSpPr/>
+          <p:nvPr/>
+        </p:nvSpPr>
+        <p:spPr>
+          <a:xfrm>
+            <a:off x="8125968" y="6793992"/>
+            <a:ext cx="2040636" cy="64008"/>
+          </a:xfrm>
+          <a:prstGeom prst="rect">
+            <a:avLst/>
+          </a:prstGeom>
+          <a:solidFill>
+            <a:srgbClr val="7FC04C"/>
+          </a:solidFill>
+          <a:ln/>
+        </p:spPr>
+        <p:txBody>
+          <a:bodyPr/>
+          <a:p/>
+        </p:txBody>
+      </p:sp>
+      <p:sp>
+        <p:nvSpPr>
+          <p:cNvPr id="17" name="Shape 12"/>
+          <p:cNvSpPr/>
+          <p:nvPr/>
+        </p:nvSpPr>
+        <p:spPr>
+          <a:xfrm>
+            <a:off x="10157460" y="6793992"/>
+            <a:ext cx="2040636" cy="64008"/>
+          </a:xfrm>
+          <a:prstGeom prst="rect">
+            <a:avLst/>
+          </a:prstGeom>
+          <a:solidFill>
+            <a:srgbClr val="E1DD57"/>
+          </a:solidFill>
+          <a:ln/>
+        </p:spPr>
+        <p:txBody>
+          <a:bodyPr/>
+          <a:p/>
+        </p:txBody>
+      </p:sp>
+      <p:sp>
+        <p:nvSpPr>
+          <p:cNvPr id="18" name="TextBox 17"/>
+          <p:cNvSpPr txBox="1"/>
+          <p:nvPr/>
+        </p:nvSpPr>
+        <p:spPr>
+          <a:xfrm>
+            <a:off x="548640" y="320040"/>
+            <a:ext cx="11064240" cy="685800"/>
+          </a:xfrm>
+          <a:prstGeom prst="rect">
+            <a:avLst/>
+          </a:prstGeom>
+          <a:noFill/>
+        </p:spPr>
+        <p:txBody>
+          <a:bodyPr wrap="none">
+            <a:spAutoFit/>
+          </a:bodyPr>
+          <a:lstStyle/>
+          <a:p>
+            <a:r>
+              <a:rPr sz="3000" b="1">
+                <a:solidFill>
+                  <a:srgbClr val="01485C"/>
+                </a:solidFill>
+              </a:rPr>
               <a:t>Getting the reports for your site</a:t>
             </a:r>
           </a:p>
@@ -4021,7 +4777,7 @@
                   <a:srgbClr val="01485C"/>
                 </a:solidFill>
               </a:rPr>
-              <a:t>Charters Towers, August 2026 — pages 1–2 of 5</a:t>
+              <a:t>Charters Towers, August 2026 — pages 1–2 of 6</a:t>
             </a:r>
           </a:p>
         </p:txBody>
@@ -4522,7 +5278,7 @@
                   <a:srgbClr val="01485C"/>
                 </a:solidFill>
               </a:rPr>
-              <a:t>Charters Towers, August 2026 — pages 3–4 of 5</a:t>
+              <a:t>Charters Towers, August 2026 — pages 3–4 of 6</a:t>
             </a:r>
           </a:p>
         </p:txBody>
@@ -5038,7 +5794,7 @@
                   <a:srgbClr val="01485C"/>
                 </a:solidFill>
               </a:rPr>
-              <a:t>Charters Towers, August 2026 — page 5 of 5</a:t>
+              <a:t>Charters Towers, August 2026 — page 5 of 6</a:t>
             </a:r>
           </a:p>
         </p:txBody>
@@ -5254,7 +6010,7 @@
                   <a:srgbClr val="17272E"/>
                 </a:solidFill>
               </a:rPr>
-              <a:t>A link to the online training resources closes every report.</a:t>
+              <a:t>The error section ends here; the last page turns to supplies.</a:t>
             </a:r>
           </a:p>
         </p:txBody>
@@ -5487,7 +6243,7 @@
                   <a:srgbClr val="01485C"/>
                 </a:solidFill>
               </a:rPr>
-              <a:t>Summaries for site leads and area managers</a:t>
+              <a:t>Charters Towers, August 2026 — page 6 of 6</a:t>
             </a:r>
           </a:p>
         </p:txBody>
@@ -5545,7 +6301,7 @@
       </p:sp>
       <p:pic>
         <p:nvPicPr>
-          <p:cNvPr id="20" name="Picture 19" descr="site_p1.png"/>
+          <p:cNvPr id="20" name="Picture 19" descr="cth_p6_top.png"/>
           <p:cNvPicPr>
             <a:picLocks noChangeAspect="1"/>
           </p:cNvPicPr>
@@ -5560,7 +6316,7 @@
         <p:spPr>
           <a:xfrm>
             <a:off x="548640" y="1143000"/>
-            <a:ext cx="3429521" cy="4846320"/>
+            <a:ext cx="11444163" cy="4846320"/>
           </a:xfrm>
           <a:prstGeom prst="rect">
             <a:avLst/>
@@ -5581,7 +6337,7 @@
         <p:spPr>
           <a:xfrm>
             <a:off x="548640" y="6035040"/>
-            <a:ext cx="3429521" cy="365760"/>
+            <a:ext cx="11444163" cy="365760"/>
           </a:xfrm>
           <a:prstGeom prst="rect">
             <a:avLst/>
@@ -5605,50 +6361,21 @@
                   <a:srgbClr val="5F7178"/>
                 </a:solidFill>
               </a:rPr>
-              <a:t>Site Overview — every ward of a large site on one page</a:t>
-            </a:r>
-          </a:p>
-        </p:txBody>
-      </p:sp>
-      <p:pic>
-        <p:nvPicPr>
-          <p:cNvPr id="22" name="Picture 21" descr="area_p1.png"/>
-          <p:cNvPicPr>
-            <a:picLocks noChangeAspect="1"/>
-          </p:cNvPicPr>
-          <p:nvPr/>
-        </p:nvPicPr>
-        <p:blipFill>
-          <a:blip r:embed="rId3"/>
-          <a:stretch>
-            <a:fillRect/>
-          </a:stretch>
-        </p:blipFill>
-        <p:spPr>
-          <a:xfrm>
-            <a:off x="4206240" y="1143000"/>
-            <a:ext cx="3429521" cy="4846320"/>
-          </a:xfrm>
-          <a:prstGeom prst="rect">
-            <a:avLst/>
-          </a:prstGeom>
-          <a:ln>
-            <a:solidFill>
-              <a:srgbClr val="E2E8EA"/>
-            </a:solidFill>
-          </a:ln>
-        </p:spPr>
-      </p:pic>
-      <p:sp>
-        <p:nvSpPr>
-          <p:cNvPr id="23" name="TextBox 22"/>
+              <a:t>Page 6: cartridge usage and an ordering guide</a:t>
+            </a:r>
+          </a:p>
+        </p:txBody>
+      </p:sp>
+      <p:sp>
+        <p:nvSpPr>
+          <p:cNvPr id="22" name="TextBox 21"/>
           <p:cNvSpPr txBox="1"/>
           <p:nvPr/>
         </p:nvSpPr>
         <p:spPr>
           <a:xfrm>
-            <a:off x="4206240" y="6035040"/>
-            <a:ext cx="3429521" cy="365760"/>
+            <a:off x="12312843" y="1188720"/>
+            <a:ext cx="-699963" cy="4846320"/>
           </a:xfrm>
           <a:prstGeom prst="rect">
             <a:avLst/>
@@ -5661,44 +6388,6 @@
           </a:bodyPr>
           <a:lstStyle/>
           <a:p>
-            <a:pPr algn="ctr">
-              <a:spcAft>
-                <a:spcPts val="600"/>
-              </a:spcAft>
-            </a:pPr>
-            <a:r>
-              <a:rPr sz="1100" b="0">
-                <a:solidFill>
-                  <a:srgbClr val="5F7178"/>
-                </a:solidFill>
-              </a:rPr>
-              <a:t>Area Summary — every hospital in the HHS</a:t>
-            </a:r>
-          </a:p>
-        </p:txBody>
-      </p:sp>
-      <p:sp>
-        <p:nvSpPr>
-          <p:cNvPr id="24" name="TextBox 23"/>
-          <p:cNvSpPr txBox="1"/>
-          <p:nvPr/>
-        </p:nvSpPr>
-        <p:spPr>
-          <a:xfrm>
-            <a:off x="8046720" y="1188720"/>
-            <a:ext cx="3566160" cy="4846320"/>
-          </a:xfrm>
-          <a:prstGeom prst="rect">
-            <a:avLst/>
-          </a:prstGeom>
-          <a:noFill/>
-        </p:spPr>
-        <p:txBody>
-          <a:bodyPr wrap="square">
-            <a:spAutoFit/>
-          </a:bodyPr>
-          <a:lstStyle/>
-          <a:p>
             <a:pPr algn="l">
               <a:spcAft>
                 <a:spcPts val="600"/>
@@ -5710,7 +6399,7 @@
                   <a:srgbClr val="01485C"/>
                 </a:solidFill>
               </a:rPr>
-              <a:t>The whole picture on one page</a:t>
+              <a:t>Page 6 — cartridges used, and how many to order</a:t>
             </a:r>
           </a:p>
           <a:p>
@@ -5725,7 +6414,7 @@
                   <a:srgbClr val="17272E"/>
                 </a:solidFill>
               </a:rPr>
-              <a:t>Site Overview: each ward’s analyser with cartridges, errors, error %, performance band, simulator runs and a ceramic pass or fail, plus a site total.</a:t>
+              <a:t>Cartridge Usage: every cartridge type the site used this month with patient and QC counts, the average and peak month over the last twelve, and a suggested monthly stock (the average plus 15%) as an ordering guide.</a:t>
             </a:r>
           </a:p>
           <a:p>
@@ -5740,7 +6429,7 @@
                   <a:srgbClr val="17272E"/>
                 </a:solidFill>
               </a:rPr>
-              <a:t>Area Summary: the same figures per hospital across the HHS, an area total, and a table of every analyser that missed simulators or ceramics.</a:t>
+              <a:t>Failed cartridges are listed separately: they are consumed too, but the export does not record their type.</a:t>
             </a:r>
           </a:p>
           <a:p>
@@ -5755,14 +6444,29 @@
                   <a:srgbClr val="17272E"/>
                 </a:solidFill>
               </a:rPr>
-              <a:t>Both are produced automatically with every run, in the same folder as the reports.</a:t>
-            </a:r>
-          </a:p>
-        </p:txBody>
-      </p:sp>
-      <p:sp>
-        <p:nvSpPr>
-          <p:cNvPr id="25" name="TextBox 24"/>
+              <a:t>Changes show up here first — at Charters Towers cTnI has dropped to zero while hs-TnI rises, so the cTnI order can fall.</a:t>
+            </a:r>
+          </a:p>
+          <a:p>
+            <a:pPr algn="l">
+              <a:spcAft>
+                <a:spcPts val="600"/>
+              </a:spcAft>
+            </a:pPr>
+            <a:r>
+              <a:rPr sz="1200" b="0">
+                <a:solidFill>
+                  <a:srgbClr val="17272E"/>
+                </a:solidFill>
+              </a:rPr>
+              <a:t>A link to the online training resources closes every report.</a:t>
+            </a:r>
+          </a:p>
+        </p:txBody>
+      </p:sp>
+      <p:sp>
+        <p:nvSpPr>
+          <p:cNvPr id="23" name="TextBox 22"/>
           <p:cNvSpPr txBox="1"/>
           <p:nvPr/>
         </p:nvSpPr>
@@ -5988,7 +6692,7 @@
                   <a:srgbClr val="01485C"/>
                 </a:solidFill>
               </a:rPr>
-              <a:t>Dormant analysers — found, left out, listed</a:t>
+              <a:t>Summaries for site leads and area managers</a:t>
             </a:r>
           </a:p>
         </p:txBody>
@@ -6046,7 +6750,7 @@
       </p:sp>
       <p:pic>
         <p:nvPicPr>
-          <p:cNvPr id="20" name="Picture 19" descr="dormant_p1.png"/>
+          <p:cNvPr id="20" name="Picture 19" descr="site_p1.png"/>
           <p:cNvPicPr>
             <a:picLocks noChangeAspect="1"/>
           </p:cNvPicPr>
@@ -6106,21 +6810,50 @@
                   <a:srgbClr val="5F7178"/>
                 </a:solidFill>
               </a:rPr>
-              <a:t>The dormant-analyser list for August 2026</a:t>
-            </a:r>
-          </a:p>
-        </p:txBody>
-      </p:sp>
-      <p:sp>
-        <p:nvSpPr>
-          <p:cNvPr id="22" name="TextBox 21"/>
+              <a:t>Site Overview — every ward of a large site on one page</a:t>
+            </a:r>
+          </a:p>
+        </p:txBody>
+      </p:sp>
+      <p:pic>
+        <p:nvPicPr>
+          <p:cNvPr id="22" name="Picture 21" descr="area_p1.png"/>
+          <p:cNvPicPr>
+            <a:picLocks noChangeAspect="1"/>
+          </p:cNvPicPr>
+          <p:nvPr/>
+        </p:nvPicPr>
+        <p:blipFill>
+          <a:blip r:embed="rId3"/>
+          <a:stretch>
+            <a:fillRect/>
+          </a:stretch>
+        </p:blipFill>
+        <p:spPr>
+          <a:xfrm>
+            <a:off x="4206240" y="1143000"/>
+            <a:ext cx="3429521" cy="4846320"/>
+          </a:xfrm>
+          <a:prstGeom prst="rect">
+            <a:avLst/>
+          </a:prstGeom>
+          <a:ln>
+            <a:solidFill>
+              <a:srgbClr val="E2E8EA"/>
+            </a:solidFill>
+          </a:ln>
+        </p:spPr>
+      </p:pic>
+      <p:sp>
+        <p:nvSpPr>
+          <p:cNvPr id="23" name="TextBox 22"/>
           <p:cNvSpPr txBox="1"/>
           <p:nvPr/>
         </p:nvSpPr>
         <p:spPr>
           <a:xfrm>
-            <a:off x="4480560" y="1188720"/>
-            <a:ext cx="7132320" cy="4846320"/>
+            <a:off x="4206240" y="6035040"/>
+            <a:ext cx="3429521" cy="365760"/>
           </a:xfrm>
           <a:prstGeom prst="rect">
             <a:avLst/>
@@ -6133,6 +6866,44 @@
           </a:bodyPr>
           <a:lstStyle/>
           <a:p>
+            <a:pPr algn="ctr">
+              <a:spcAft>
+                <a:spcPts val="600"/>
+              </a:spcAft>
+            </a:pPr>
+            <a:r>
+              <a:rPr sz="1100" b="0">
+                <a:solidFill>
+                  <a:srgbClr val="5F7178"/>
+                </a:solidFill>
+              </a:rPr>
+              <a:t>Area Summary — every hospital in the HHS</a:t>
+            </a:r>
+          </a:p>
+        </p:txBody>
+      </p:sp>
+      <p:sp>
+        <p:nvSpPr>
+          <p:cNvPr id="24" name="TextBox 23"/>
+          <p:cNvSpPr txBox="1"/>
+          <p:nvPr/>
+        </p:nvSpPr>
+        <p:spPr>
+          <a:xfrm>
+            <a:off x="8046720" y="1188720"/>
+            <a:ext cx="3566160" cy="4846320"/>
+          </a:xfrm>
+          <a:prstGeom prst="rect">
+            <a:avLst/>
+          </a:prstGeom>
+          <a:noFill/>
+        </p:spPr>
+        <p:txBody>
+          <a:bodyPr wrap="square">
+            <a:spAutoFit/>
+          </a:bodyPr>
+          <a:lstStyle/>
+          <a:p>
             <a:pPr algn="l">
               <a:spcAft>
                 <a:spcPts val="600"/>
@@ -6144,7 +6915,7 @@
                   <a:srgbClr val="01485C"/>
                 </a:solidFill>
               </a:rPr>
-              <a:t>The four-month rule</a:t>
+              <a:t>The whole picture on one page</a:t>
             </a:r>
           </a:p>
           <a:p>
@@ -6159,7 +6930,7 @@
                   <a:srgbClr val="17272E"/>
                 </a:solidFill>
               </a:rPr>
-              <a:t>An analyser with no cartridges, no simulator runs and no ceramic cleaning for four consecutive months is dormant: it gets no report and no longer counts against its site’s checks.</a:t>
+              <a:t>Site Overview: each ward’s analyser with cartridges, errors, error %, performance band, simulator runs and a ceramic pass or fail, plus a site total.</a:t>
             </a:r>
           </a:p>
           <a:p>
@@ -6174,7 +6945,7 @@
                   <a:srgbClr val="17272E"/>
                 </a:solidFill>
               </a:rPr>
-              <a:t>One or two quiet months change nothing. The reports exist to catch wards skipping simulators, so nothing is removed early.</a:t>
+              <a:t>Area Summary: the same figures per hospital across the HHS, an area total, and a table of every analyser that missed simulators or ceramics.</a:t>
             </a:r>
           </a:p>
           <a:p>
@@ -6189,29 +6960,14 @@
                   <a:srgbClr val="17272E"/>
                 </a:solidFill>
               </a:rPr>
-              <a:t>Any use brings the unit straight back the next month.</a:t>
-            </a:r>
-          </a:p>
-          <a:p>
-            <a:pPr algn="l">
-              <a:spcAft>
-                <a:spcPts val="600"/>
-              </a:spcAft>
-            </a:pPr>
-            <a:r>
-              <a:rPr sz="1200" b="0">
-                <a:solidFill>
-                  <a:srgbClr val="17272E"/>
-                </a:solidFill>
-              </a:rPr>
-              <a:t>Every run writes the list: hospital, location, serial, months idle and last activity. In August 2026, 163 units — mostly old models sitting beside their replacements — a ready-made retirement list.</a:t>
-            </a:r>
-          </a:p>
-        </p:txBody>
-      </p:sp>
-      <p:sp>
-        <p:nvSpPr>
-          <p:cNvPr id="23" name="TextBox 22"/>
+              <a:t>Both are produced automatically with every run, in the same folder as the reports.</a:t>
+            </a:r>
+          </a:p>
+        </p:txBody>
+      </p:sp>
+      <p:sp>
+        <p:nvSpPr>
+          <p:cNvPr id="25" name="TextBox 24"/>
           <p:cNvSpPr txBox="1"/>
           <p:nvPr/>
         </p:nvSpPr>
@@ -6437,7 +7193,7 @@
                   <a:srgbClr val="01485C"/>
                 </a:solidFill>
               </a:rPr>
-              <a:t>How it protects the data</a:t>
+              <a:t>Dormant analysers — found, left out, listed</a:t>
             </a:r>
           </a:p>
         </p:txBody>
@@ -6450,16 +7206,14 @@
         </p:nvSpPr>
         <p:spPr>
           <a:xfrm>
-            <a:off x="548640" y="1280160"/>
-            <a:ext cx="5440680" cy="2103120"/>
+            <a:off x="9784080" y="384048"/>
+            <a:ext cx="1828800" cy="457200"/>
           </a:xfrm>
           <a:prstGeom prst="roundRect">
-            <a:avLst>
-              <a:gd name="adj" fmla="val 8000"/>
-            </a:avLst>
-          </a:prstGeom>
-          <a:solidFill>
-            <a:srgbClr val="E5F2F0"/>
+            <a:avLst/>
+          </a:prstGeom>
+          <a:solidFill>
+            <a:srgbClr val="01485C"/>
           </a:solidFill>
           <a:ln>
             <a:noFill/>
@@ -6484,19 +7238,56 @@
           <a:lstStyle/>
           <a:p>
             <a:pPr algn="ctr"/>
-          </a:p>
-        </p:txBody>
-      </p:sp>
-      <p:sp>
-        <p:nvSpPr>
-          <p:cNvPr id="20" name="TextBox 19"/>
+            <a:r>
+              <a:rPr sz="1500" b="1">
+                <a:solidFill>
+                  <a:srgbClr val="FFFFFF"/>
+                </a:solidFill>
+              </a:rPr>
+              <a:t>i-STAT</a:t>
+            </a:r>
+          </a:p>
+        </p:txBody>
+      </p:sp>
+      <p:pic>
+        <p:nvPicPr>
+          <p:cNvPr id="20" name="Picture 19" descr="dormant_p1.png"/>
+          <p:cNvPicPr>
+            <a:picLocks noChangeAspect="1"/>
+          </p:cNvPicPr>
+          <p:nvPr/>
+        </p:nvPicPr>
+        <p:blipFill>
+          <a:blip r:embed="rId2"/>
+          <a:stretch>
+            <a:fillRect/>
+          </a:stretch>
+        </p:blipFill>
+        <p:spPr>
+          <a:xfrm>
+            <a:off x="548640" y="1143000"/>
+            <a:ext cx="3429521" cy="4846320"/>
+          </a:xfrm>
+          <a:prstGeom prst="rect">
+            <a:avLst/>
+          </a:prstGeom>
+          <a:ln>
+            <a:solidFill>
+              <a:srgbClr val="E2E8EA"/>
+            </a:solidFill>
+          </a:ln>
+        </p:spPr>
+      </p:pic>
+      <p:sp>
+        <p:nvSpPr>
+          <p:cNvPr id="21" name="TextBox 20"/>
           <p:cNvSpPr txBox="1"/>
           <p:nvPr/>
         </p:nvSpPr>
         <p:spPr>
           <a:xfrm>
-            <a:off x="777240" y="1417319"/>
-            <a:ext cx="4983480" cy="457200"/>
+            <a:off x="548640" y="6035040"/>
+            <a:ext cx="3429521" cy="365760"/>
           </a:xfrm>
           <a:prstGeom prst="rect">
             <a:avLst/>
@@ -6509,32 +7300,32 @@
           </a:bodyPr>
           <a:lstStyle/>
           <a:p>
-            <a:pPr algn="l">
-              <a:spcAft>
-                <a:spcPts val="600"/>
-              </a:spcAft>
-            </a:pPr>
-            <a:r>
-              <a:rPr sz="1500" b="1">
-                <a:solidFill>
-                  <a:srgbClr val="01485C"/>
-                </a:solidFill>
-              </a:rPr>
-              <a:t>Runs from an encrypted USB drive</a:t>
-            </a:r>
-          </a:p>
-        </p:txBody>
-      </p:sp>
-      <p:sp>
-        <p:nvSpPr>
-          <p:cNvPr id="21" name="TextBox 20"/>
+            <a:pPr algn="ctr">
+              <a:spcAft>
+                <a:spcPts val="600"/>
+              </a:spcAft>
+            </a:pPr>
+            <a:r>
+              <a:rPr sz="1100" b="0">
+                <a:solidFill>
+                  <a:srgbClr val="5F7178"/>
+                </a:solidFill>
+              </a:rPr>
+              <a:t>The dormant-analyser list for August 2026</a:t>
+            </a:r>
+          </a:p>
+        </p:txBody>
+      </p:sp>
+      <p:sp>
+        <p:nvSpPr>
+          <p:cNvPr id="22" name="TextBox 21"/>
           <p:cNvSpPr txBox="1"/>
           <p:nvPr/>
         </p:nvSpPr>
         <p:spPr>
           <a:xfrm>
-            <a:off x="777240" y="1847088"/>
-            <a:ext cx="4983480" cy="1463039"/>
+            <a:off x="4480560" y="1188720"/>
+            <a:ext cx="7132320" cy="4846320"/>
           </a:xfrm>
           <a:prstGeom prst="rect">
             <a:avLst/>
@@ -6553,420 +7344,79 @@
               </a:spcAft>
             </a:pPr>
             <a:r>
+              <a:rPr sz="1500" b="1">
+                <a:solidFill>
+                  <a:srgbClr val="01485C"/>
+                </a:solidFill>
+              </a:rPr>
+              <a:t>The four-month rule</a:t>
+            </a:r>
+          </a:p>
+          <a:p>
+            <a:pPr algn="l">
+              <a:spcAft>
+                <a:spcPts val="600"/>
+              </a:spcAft>
+            </a:pPr>
+            <a:r>
               <a:rPr sz="1200" b="0">
                 <a:solidFill>
                   <a:srgbClr val="17272E"/>
                 </a:solidFill>
               </a:rPr>
-              <a:t>Its own Python runtime, no installation, no admin rights, no changes to the PC. BitLocker To Go encrypts the whole drive.</a:t>
-            </a:r>
-          </a:p>
-        </p:txBody>
-      </p:sp>
-      <p:sp>
-        <p:nvSpPr>
-          <p:cNvPr id="22" name="Rounded Rectangle 21"/>
-          <p:cNvSpPr/>
-          <p:nvPr/>
-        </p:nvSpPr>
-        <p:spPr>
-          <a:xfrm>
-            <a:off x="6172200" y="1280160"/>
-            <a:ext cx="5440680" cy="2103120"/>
-          </a:xfrm>
-          <a:prstGeom prst="roundRect">
-            <a:avLst>
-              <a:gd name="adj" fmla="val 8000"/>
-            </a:avLst>
-          </a:prstGeom>
-          <a:solidFill>
-            <a:srgbClr val="E5F2F0"/>
-          </a:solidFill>
-          <a:ln>
-            <a:noFill/>
-          </a:ln>
-        </p:spPr>
-        <p:style>
-          <a:lnRef idx="1">
-            <a:schemeClr val="accent1"/>
-          </a:lnRef>
-          <a:fillRef idx="3">
-            <a:schemeClr val="accent1"/>
-          </a:fillRef>
-          <a:effectRef idx="2">
-            <a:schemeClr val="accent1"/>
-          </a:effectRef>
-          <a:fontRef idx="minor">
-            <a:schemeClr val="lt1"/>
-          </a:fontRef>
-        </p:style>
-        <p:txBody>
-          <a:bodyPr rtlCol="0" anchor="ctr"/>
-          <a:lstStyle/>
-          <a:p>
-            <a:pPr algn="ctr"/>
+              <a:t>An analyser with no cartridges, no simulator runs and no ceramic cleaning for four consecutive months is dormant: it gets no report and no longer counts against its site’s checks.</a:t>
+            </a:r>
+          </a:p>
+          <a:p>
+            <a:pPr algn="l">
+              <a:spcAft>
+                <a:spcPts val="600"/>
+              </a:spcAft>
+            </a:pPr>
+            <a:r>
+              <a:rPr sz="1200" b="0">
+                <a:solidFill>
+                  <a:srgbClr val="17272E"/>
+                </a:solidFill>
+              </a:rPr>
+              <a:t>One or two quiet months change nothing. The reports exist to catch wards skipping simulators, so nothing is removed early.</a:t>
+            </a:r>
+          </a:p>
+          <a:p>
+            <a:pPr algn="l">
+              <a:spcAft>
+                <a:spcPts val="600"/>
+              </a:spcAft>
+            </a:pPr>
+            <a:r>
+              <a:rPr sz="1200" b="0">
+                <a:solidFill>
+                  <a:srgbClr val="17272E"/>
+                </a:solidFill>
+              </a:rPr>
+              <a:t>Any use brings the unit straight back the next month.</a:t>
+            </a:r>
+          </a:p>
+          <a:p>
+            <a:pPr algn="l">
+              <a:spcAft>
+                <a:spcPts val="600"/>
+              </a:spcAft>
+            </a:pPr>
+            <a:r>
+              <a:rPr sz="1200" b="0">
+                <a:solidFill>
+                  <a:srgbClr val="17272E"/>
+                </a:solidFill>
+              </a:rPr>
+              <a:t>Every run writes the list: hospital, location, serial, months idle and last activity. In August 2026, 163 units — mostly old models sitting beside their replacements — a ready-made retirement list.</a:t>
+            </a:r>
           </a:p>
         </p:txBody>
       </p:sp>
       <p:sp>
         <p:nvSpPr>
           <p:cNvPr id="23" name="TextBox 22"/>
-          <p:cNvSpPr txBox="1"/>
-          <p:nvPr/>
-        </p:nvSpPr>
-        <p:spPr>
-          <a:xfrm>
-            <a:off x="6400800" y="1417319"/>
-            <a:ext cx="4983480" cy="457200"/>
-          </a:xfrm>
-          <a:prstGeom prst="rect">
-            <a:avLst/>
-          </a:prstGeom>
-          <a:noFill/>
-        </p:spPr>
-        <p:txBody>
-          <a:bodyPr wrap="square">
-            <a:spAutoFit/>
-          </a:bodyPr>
-          <a:lstStyle/>
-          <a:p>
-            <a:pPr algn="l">
-              <a:spcAft>
-                <a:spcPts val="600"/>
-              </a:spcAft>
-            </a:pPr>
-            <a:r>
-              <a:rPr sz="1500" b="1">
-                <a:solidFill>
-                  <a:srgbClr val="01485C"/>
-                </a:solidFill>
-              </a:rPr>
-              <a:t>Offline by enforcement</a:t>
-            </a:r>
-          </a:p>
-        </p:txBody>
-      </p:sp>
-      <p:sp>
-        <p:nvSpPr>
-          <p:cNvPr id="24" name="TextBox 23"/>
-          <p:cNvSpPr txBox="1"/>
-          <p:nvPr/>
-        </p:nvSpPr>
-        <p:spPr>
-          <a:xfrm>
-            <a:off x="6400800" y="1847088"/>
-            <a:ext cx="4983480" cy="1463039"/>
-          </a:xfrm>
-          <a:prstGeom prst="rect">
-            <a:avLst/>
-          </a:prstGeom>
-          <a:noFill/>
-        </p:spPr>
-        <p:txBody>
-          <a:bodyPr wrap="square">
-            <a:spAutoFit/>
-          </a:bodyPr>
-          <a:lstStyle/>
-          <a:p>
-            <a:pPr algn="l">
-              <a:spcAft>
-                <a:spcPts val="600"/>
-              </a:spcAft>
-            </a:pPr>
-            <a:r>
-              <a:rPr sz="1200" b="0">
-                <a:solidFill>
-                  <a:srgbClr val="17272E"/>
-                </a:solidFill>
-              </a:rPr>
-              <a:t>All three servers bind to the local machine only, and a runtime guard blocks and logs any attempt to reach the network. Zero outbound connections, ever.</a:t>
-            </a:r>
-          </a:p>
-        </p:txBody>
-      </p:sp>
-      <p:sp>
-        <p:nvSpPr>
-          <p:cNvPr id="25" name="Rounded Rectangle 24"/>
-          <p:cNvSpPr/>
-          <p:nvPr/>
-        </p:nvSpPr>
-        <p:spPr>
-          <a:xfrm>
-            <a:off x="548640" y="3566160"/>
-            <a:ext cx="5440680" cy="2103120"/>
-          </a:xfrm>
-          <a:prstGeom prst="roundRect">
-            <a:avLst>
-              <a:gd name="adj" fmla="val 8000"/>
-            </a:avLst>
-          </a:prstGeom>
-          <a:solidFill>
-            <a:srgbClr val="FDF0E4"/>
-          </a:solidFill>
-          <a:ln>
-            <a:noFill/>
-          </a:ln>
-        </p:spPr>
-        <p:style>
-          <a:lnRef idx="1">
-            <a:schemeClr val="accent1"/>
-          </a:lnRef>
-          <a:fillRef idx="3">
-            <a:schemeClr val="accent1"/>
-          </a:fillRef>
-          <a:effectRef idx="2">
-            <a:schemeClr val="accent1"/>
-          </a:effectRef>
-          <a:fontRef idx="minor">
-            <a:schemeClr val="lt1"/>
-          </a:fontRef>
-        </p:style>
-        <p:txBody>
-          <a:bodyPr rtlCol="0" anchor="ctr"/>
-          <a:lstStyle/>
-          <a:p>
-            <a:pPr algn="ctr"/>
-          </a:p>
-        </p:txBody>
-      </p:sp>
-      <p:sp>
-        <p:nvSpPr>
-          <p:cNvPr id="26" name="TextBox 25"/>
-          <p:cNvSpPr txBox="1"/>
-          <p:nvPr/>
-        </p:nvSpPr>
-        <p:spPr>
-          <a:xfrm>
-            <a:off x="777240" y="3703320"/>
-            <a:ext cx="4983480" cy="457200"/>
-          </a:xfrm>
-          <a:prstGeom prst="rect">
-            <a:avLst/>
-          </a:prstGeom>
-          <a:noFill/>
-        </p:spPr>
-        <p:txBody>
-          <a:bodyPr wrap="square">
-            <a:spAutoFit/>
-          </a:bodyPr>
-          <a:lstStyle/>
-          <a:p>
-            <a:pPr algn="l">
-              <a:spcAft>
-                <a:spcPts val="600"/>
-              </a:spcAft>
-            </a:pPr>
-            <a:r>
-              <a:rPr sz="1500" b="1">
-                <a:solidFill>
-                  <a:srgbClr val="B4540A"/>
-                </a:solidFill>
-              </a:rPr>
-              <a:t>Named staff data encrypted</a:t>
-            </a:r>
-          </a:p>
-        </p:txBody>
-      </p:sp>
-      <p:sp>
-        <p:nvSpPr>
-          <p:cNvPr id="27" name="TextBox 26"/>
-          <p:cNvSpPr txBox="1"/>
-          <p:nvPr/>
-        </p:nvSpPr>
-        <p:spPr>
-          <a:xfrm>
-            <a:off x="777240" y="4133087"/>
-            <a:ext cx="4983480" cy="1463039"/>
-          </a:xfrm>
-          <a:prstGeom prst="rect">
-            <a:avLst/>
-          </a:prstGeom>
-          <a:noFill/>
-        </p:spPr>
-        <p:txBody>
-          <a:bodyPr wrap="square">
-            <a:spAutoFit/>
-          </a:bodyPr>
-          <a:lstStyle/>
-          <a:p>
-            <a:pPr algn="l">
-              <a:spcAft>
-                <a:spcPts val="600"/>
-              </a:spcAft>
-            </a:pPr>
-            <a:r>
-              <a:rPr sz="1200" b="0">
-                <a:solidFill>
-                  <a:srgbClr val="17272E"/>
-                </a:solidFill>
-              </a:rPr>
-              <a:t>The rolling staff and device history is AES-encrypted with a password that is never stored. Reports cannot be generated until it is unlocked.</a:t>
-            </a:r>
-          </a:p>
-        </p:txBody>
-      </p:sp>
-      <p:sp>
-        <p:nvSpPr>
-          <p:cNvPr id="28" name="Rounded Rectangle 27"/>
-          <p:cNvSpPr/>
-          <p:nvPr/>
-        </p:nvSpPr>
-        <p:spPr>
-          <a:xfrm>
-            <a:off x="6172200" y="3566160"/>
-            <a:ext cx="5440680" cy="2103120"/>
-          </a:xfrm>
-          <a:prstGeom prst="roundRect">
-            <a:avLst>
-              <a:gd name="adj" fmla="val 8000"/>
-            </a:avLst>
-          </a:prstGeom>
-          <a:solidFill>
-            <a:srgbClr val="E5F2F0"/>
-          </a:solidFill>
-          <a:ln>
-            <a:noFill/>
-          </a:ln>
-        </p:spPr>
-        <p:style>
-          <a:lnRef idx="1">
-            <a:schemeClr val="accent1"/>
-          </a:lnRef>
-          <a:fillRef idx="3">
-            <a:schemeClr val="accent1"/>
-          </a:fillRef>
-          <a:effectRef idx="2">
-            <a:schemeClr val="accent1"/>
-          </a:effectRef>
-          <a:fontRef idx="minor">
-            <a:schemeClr val="lt1"/>
-          </a:fontRef>
-        </p:style>
-        <p:txBody>
-          <a:bodyPr rtlCol="0" anchor="ctr"/>
-          <a:lstStyle/>
-          <a:p>
-            <a:pPr algn="ctr"/>
-          </a:p>
-        </p:txBody>
-      </p:sp>
-      <p:sp>
-        <p:nvSpPr>
-          <p:cNvPr id="29" name="TextBox 28"/>
-          <p:cNvSpPr txBox="1"/>
-          <p:nvPr/>
-        </p:nvSpPr>
-        <p:spPr>
-          <a:xfrm>
-            <a:off x="6400800" y="3703320"/>
-            <a:ext cx="4983480" cy="457200"/>
-          </a:xfrm>
-          <a:prstGeom prst="rect">
-            <a:avLst/>
-          </a:prstGeom>
-          <a:noFill/>
-        </p:spPr>
-        <p:txBody>
-          <a:bodyPr wrap="square">
-            <a:spAutoFit/>
-          </a:bodyPr>
-          <a:lstStyle/>
-          <a:p>
-            <a:pPr algn="l">
-              <a:spcAft>
-                <a:spcPts val="600"/>
-              </a:spcAft>
-            </a:pPr>
-            <a:r>
-              <a:rPr sz="1500" b="1">
-                <a:solidFill>
-                  <a:srgbClr val="01485C"/>
-                </a:solidFill>
-              </a:rPr>
-              <a:t>Controlled roll-out</a:t>
-            </a:r>
-          </a:p>
-        </p:txBody>
-      </p:sp>
-      <p:sp>
-        <p:nvSpPr>
-          <p:cNvPr id="30" name="TextBox 29"/>
-          <p:cNvSpPr txBox="1"/>
-          <p:nvPr/>
-        </p:nvSpPr>
-        <p:spPr>
-          <a:xfrm>
-            <a:off x="6400800" y="4133087"/>
-            <a:ext cx="4983480" cy="1463039"/>
-          </a:xfrm>
-          <a:prstGeom prst="rect">
-            <a:avLst/>
-          </a:prstGeom>
-          <a:noFill/>
-        </p:spPr>
-        <p:txBody>
-          <a:bodyPr wrap="square">
-            <a:spAutoFit/>
-          </a:bodyPr>
-          <a:lstStyle/>
-          <a:p>
-            <a:pPr algn="l">
-              <a:spcAft>
-                <a:spcPts val="600"/>
-              </a:spcAft>
-            </a:pPr>
-            <a:r>
-              <a:rPr sz="1200" b="0">
-                <a:solidFill>
-                  <a:srgbClr val="17272E"/>
-                </a:solidFill>
-              </a:rPr>
-              <a:t>It runs only on PCs approved by the PoC lead, reviewed on the 12-month QIS cycle, with an audit trail of every launch and every report generated.</a:t>
-            </a:r>
-          </a:p>
-        </p:txBody>
-      </p:sp>
-      <p:sp>
-        <p:nvSpPr>
-          <p:cNvPr id="31" name="TextBox 30"/>
-          <p:cNvSpPr txBox="1"/>
-          <p:nvPr/>
-        </p:nvSpPr>
-        <p:spPr>
-          <a:xfrm>
-            <a:off x="548640" y="5806440"/>
-            <a:ext cx="11064240" cy="411480"/>
-          </a:xfrm>
-          <a:prstGeom prst="rect">
-            <a:avLst/>
-          </a:prstGeom>
-          <a:noFill/>
-        </p:spPr>
-        <p:txBody>
-          <a:bodyPr wrap="square">
-            <a:spAutoFit/>
-          </a:bodyPr>
-          <a:lstStyle/>
-          <a:p>
-            <a:pPr algn="l">
-              <a:spcAft>
-                <a:spcPts val="600"/>
-              </a:spcAft>
-            </a:pPr>
-            <a:r>
-              <a:rPr sz="1100" b="0">
-                <a:solidFill>
-                  <a:srgbClr val="5F7178"/>
-                </a:solidFill>
-              </a:rPr>
-              <a:t>Full detail for IT: SECURITY_README.md on the drive and the Security Briefing deck.</a:t>
-            </a:r>
-          </a:p>
-        </p:txBody>
-      </p:sp>
-      <p:sp>
-        <p:nvSpPr>
-          <p:cNvPr id="32" name="TextBox 31"/>
           <p:cNvSpPr txBox="1"/>
           <p:nvPr/>
         </p:nvSpPr>

</xml_diff>